<commit_message>
Update exam for CP2506E class
</commit_message>
<xml_diff>
--- a/Slide/MicroController/08.Timer.pptx
+++ b/Slide/MicroController/08.Timer.pptx
@@ -262,7 +262,7 @@
           <a:p>
             <a:fld id="{ECA3AE87-C17F-4F2C-92FF-7FE21F8A66BE}" type="datetimeFigureOut">
               <a:rPr lang="en-US" smtClean="0"/>
-              <a:t>2/11/2025</a:t>
+              <a:t>6/23/2025</a:t>
             </a:fld>
             <a:endParaRPr lang="en-US"/>
           </a:p>
@@ -430,7 +430,7 @@
           <a:p>
             <a:fld id="{ECA3AE87-C17F-4F2C-92FF-7FE21F8A66BE}" type="datetimeFigureOut">
               <a:rPr lang="en-US" smtClean="0"/>
-              <a:t>2/11/2025</a:t>
+              <a:t>6/23/2025</a:t>
             </a:fld>
             <a:endParaRPr lang="en-US"/>
           </a:p>
@@ -608,7 +608,7 @@
           <a:p>
             <a:fld id="{ECA3AE87-C17F-4F2C-92FF-7FE21F8A66BE}" type="datetimeFigureOut">
               <a:rPr lang="en-US" smtClean="0"/>
-              <a:t>2/11/2025</a:t>
+              <a:t>6/23/2025</a:t>
             </a:fld>
             <a:endParaRPr lang="en-US"/>
           </a:p>
@@ -776,7 +776,7 @@
           <a:p>
             <a:fld id="{ECA3AE87-C17F-4F2C-92FF-7FE21F8A66BE}" type="datetimeFigureOut">
               <a:rPr lang="en-US" smtClean="0"/>
-              <a:t>2/11/2025</a:t>
+              <a:t>6/23/2025</a:t>
             </a:fld>
             <a:endParaRPr lang="en-US"/>
           </a:p>
@@ -1021,7 +1021,7 @@
           <a:p>
             <a:fld id="{ECA3AE87-C17F-4F2C-92FF-7FE21F8A66BE}" type="datetimeFigureOut">
               <a:rPr lang="en-US" smtClean="0"/>
-              <a:t>2/11/2025</a:t>
+              <a:t>6/23/2025</a:t>
             </a:fld>
             <a:endParaRPr lang="en-US"/>
           </a:p>
@@ -1250,7 +1250,7 @@
           <a:p>
             <a:fld id="{ECA3AE87-C17F-4F2C-92FF-7FE21F8A66BE}" type="datetimeFigureOut">
               <a:rPr lang="en-US" smtClean="0"/>
-              <a:t>2/11/2025</a:t>
+              <a:t>6/23/2025</a:t>
             </a:fld>
             <a:endParaRPr lang="en-US"/>
           </a:p>
@@ -1614,7 +1614,7 @@
           <a:p>
             <a:fld id="{ECA3AE87-C17F-4F2C-92FF-7FE21F8A66BE}" type="datetimeFigureOut">
               <a:rPr lang="en-US" smtClean="0"/>
-              <a:t>2/11/2025</a:t>
+              <a:t>6/23/2025</a:t>
             </a:fld>
             <a:endParaRPr lang="en-US"/>
           </a:p>
@@ -1731,7 +1731,7 @@
           <a:p>
             <a:fld id="{ECA3AE87-C17F-4F2C-92FF-7FE21F8A66BE}" type="datetimeFigureOut">
               <a:rPr lang="en-US" smtClean="0"/>
-              <a:t>2/11/2025</a:t>
+              <a:t>6/23/2025</a:t>
             </a:fld>
             <a:endParaRPr lang="en-US"/>
           </a:p>
@@ -1826,7 +1826,7 @@
           <a:p>
             <a:fld id="{ECA3AE87-C17F-4F2C-92FF-7FE21F8A66BE}" type="datetimeFigureOut">
               <a:rPr lang="en-US" smtClean="0"/>
-              <a:t>2/11/2025</a:t>
+              <a:t>6/23/2025</a:t>
             </a:fld>
             <a:endParaRPr lang="en-US"/>
           </a:p>
@@ -2101,7 +2101,7 @@
           <a:p>
             <a:fld id="{ECA3AE87-C17F-4F2C-92FF-7FE21F8A66BE}" type="datetimeFigureOut">
               <a:rPr lang="en-US" smtClean="0"/>
-              <a:t>2/11/2025</a:t>
+              <a:t>6/23/2025</a:t>
             </a:fld>
             <a:endParaRPr lang="en-US"/>
           </a:p>
@@ -2353,7 +2353,7 @@
           <a:p>
             <a:fld id="{ECA3AE87-C17F-4F2C-92FF-7FE21F8A66BE}" type="datetimeFigureOut">
               <a:rPr lang="en-US" smtClean="0"/>
-              <a:t>2/11/2025</a:t>
+              <a:t>6/23/2025</a:t>
             </a:fld>
             <a:endParaRPr lang="en-US"/>
           </a:p>
@@ -2564,7 +2564,7 @@
           <a:p>
             <a:fld id="{ECA3AE87-C17F-4F2C-92FF-7FE21F8A66BE}" type="datetimeFigureOut">
               <a:rPr lang="en-US" smtClean="0"/>
-              <a:t>2/11/2025</a:t>
+              <a:t>6/23/2025</a:t>
             </a:fld>
             <a:endParaRPr lang="en-US"/>
           </a:p>

</xml_diff>